<commit_message>
docs: update calibration-experiments slide deck
Re-saved copy of the 8-slide deck (1.14 MB -> 1.30 MB), last edited
2026-09-12 after the initial python-pptx build.

Co-Authored-By: Claude Opus 5.5 <noreply@anthropic.com>
</commit_message>
<xml_diff>
--- a/docs/CALIBRATION_EXPERIMENTS_SLIDES_20260912.pptx
+++ b/docs/CALIBRATION_EXPERIMENTS_SLIDES_20260912.pptx
@@ -5,16 +5,16 @@
     <p:sldMasterId id="2147483648" r:id="rId1"/>
   </p:sldMasterIdLst>
   <p:sldIdLst>
-    <p:sldId id="256" r:id="rId7"/>
-    <p:sldId id="257" r:id="rId8"/>
-    <p:sldId id="258" r:id="rId9"/>
-    <p:sldId id="259" r:id="rId10"/>
-    <p:sldId id="260" r:id="rId11"/>
-    <p:sldId id="261" r:id="rId12"/>
-    <p:sldId id="262" r:id="rId13"/>
-    <p:sldId id="263" r:id="rId14"/>
+    <p:sldId id="256" r:id="rId2"/>
+    <p:sldId id="257" r:id="rId3"/>
+    <p:sldId id="258" r:id="rId4"/>
+    <p:sldId id="259" r:id="rId5"/>
+    <p:sldId id="260" r:id="rId6"/>
+    <p:sldId id="261" r:id="rId7"/>
+    <p:sldId id="262" r:id="rId8"/>
+    <p:sldId id="263" r:id="rId9"/>
   </p:sldIdLst>
-  <p:sldSz cx="12191695" cy="6858000" type="screen4x3"/>
+  <p:sldSz cx="12192000" cy="6858000"/>
   <p:notesSz cx="6858000" cy="9144000"/>
   <p:defaultTextStyle>
     <a:defPPr>
@@ -111,6 +111,22 @@
       </a:defRPr>
     </a:lvl9pPr>
   </p:defaultTextStyle>
+  <p:extLst>
+    <p:ext uri="{EFAFB233-063F-42B5-8137-9DF3F51BA10A}">
+      <p15:sldGuideLst xmlns:p15="http://schemas.microsoft.com/office/powerpoint/2012/main">
+        <p15:guide id="1" orient="horz" pos="2160">
+          <p15:clr>
+            <a:srgbClr val="A4A3A4"/>
+          </p15:clr>
+        </p15:guide>
+        <p15:guide id="2" pos="2880">
+          <p15:clr>
+            <a:srgbClr val="A4A3A4"/>
+          </p15:clr>
+        </p15:guide>
+      </p15:sldGuideLst>
+    </p:ext>
+  </p:extLst>
 </p:presentation>
 </file>
 
@@ -152,10 +168,9 @@
           <a:lstStyle/>
           <a:p>
             <a:r>
-              <a:rPr lang="en-US" smtClean="0"/>
+              <a:rPr lang="en-US"/>
               <a:t>Click to edit Master title style</a:t>
             </a:r>
-            <a:endParaRPr lang="en-US"/>
           </a:p>
         </p:txBody>
       </p:sp>
@@ -271,10 +286,9 @@
           </a:lstStyle>
           <a:p>
             <a:r>
-              <a:rPr lang="en-US" smtClean="0"/>
+              <a:rPr lang="en-US"/>
               <a:t>Click to edit Master subtitle style</a:t>
             </a:r>
-            <a:endParaRPr lang="en-US"/>
           </a:p>
         </p:txBody>
       </p:sp>
@@ -295,7 +309,7 @@
           <a:p>
             <a:fld id="{5BCAD085-E8A6-8845-BD4E-CB4CCA059FC4}" type="datetimeFigureOut">
               <a:rPr lang="en-US" smtClean="0"/>
-              <a:t>1/27/13</a:t>
+              <a:t>9/12/2026</a:t>
             </a:fld>
             <a:endParaRPr lang="en-US"/>
           </a:p>
@@ -389,10 +403,9 @@
           <a:lstStyle/>
           <a:p>
             <a:r>
-              <a:rPr lang="en-US" smtClean="0"/>
+              <a:rPr lang="en-US"/>
               <a:t>Click to edit Master title style</a:t>
             </a:r>
-            <a:endParaRPr lang="en-US"/>
           </a:p>
         </p:txBody>
       </p:sp>
@@ -413,38 +426,37 @@
           <a:p>
             <a:pPr lvl="0"/>
             <a:r>
-              <a:rPr lang="en-US" smtClean="0"/>
+              <a:rPr lang="en-US"/>
               <a:t>Click to edit Master text styles</a:t>
             </a:r>
           </a:p>
           <a:p>
             <a:pPr lvl="1"/>
             <a:r>
-              <a:rPr lang="en-US" smtClean="0"/>
+              <a:rPr lang="en-US"/>
               <a:t>Second level</a:t>
             </a:r>
           </a:p>
           <a:p>
             <a:pPr lvl="2"/>
             <a:r>
-              <a:rPr lang="en-US" smtClean="0"/>
+              <a:rPr lang="en-US"/>
               <a:t>Third level</a:t>
             </a:r>
           </a:p>
           <a:p>
             <a:pPr lvl="3"/>
             <a:r>
-              <a:rPr lang="en-US" smtClean="0"/>
+              <a:rPr lang="en-US"/>
               <a:t>Fourth level</a:t>
             </a:r>
           </a:p>
           <a:p>
             <a:pPr lvl="4"/>
             <a:r>
-              <a:rPr lang="en-US" smtClean="0"/>
+              <a:rPr lang="en-US"/>
               <a:t>Fifth level</a:t>
             </a:r>
-            <a:endParaRPr lang="en-US"/>
           </a:p>
         </p:txBody>
       </p:sp>
@@ -465,7 +477,7 @@
           <a:p>
             <a:fld id="{5BCAD085-E8A6-8845-BD4E-CB4CCA059FC4}" type="datetimeFigureOut">
               <a:rPr lang="en-US" smtClean="0"/>
-              <a:t>1/27/13</a:t>
+              <a:t>9/12/2026</a:t>
             </a:fld>
             <a:endParaRPr lang="en-US"/>
           </a:p>
@@ -564,10 +576,9 @@
           <a:lstStyle/>
           <a:p>
             <a:r>
-              <a:rPr lang="en-US" smtClean="0"/>
+              <a:rPr lang="en-US"/>
               <a:t>Click to edit Master title style</a:t>
             </a:r>
-            <a:endParaRPr lang="en-US"/>
           </a:p>
         </p:txBody>
       </p:sp>
@@ -593,38 +604,37 @@
           <a:p>
             <a:pPr lvl="0"/>
             <a:r>
-              <a:rPr lang="en-US" smtClean="0"/>
+              <a:rPr lang="en-US"/>
               <a:t>Click to edit Master text styles</a:t>
             </a:r>
           </a:p>
           <a:p>
             <a:pPr lvl="1"/>
             <a:r>
-              <a:rPr lang="en-US" smtClean="0"/>
+              <a:rPr lang="en-US"/>
               <a:t>Second level</a:t>
             </a:r>
           </a:p>
           <a:p>
             <a:pPr lvl="2"/>
             <a:r>
-              <a:rPr lang="en-US" smtClean="0"/>
+              <a:rPr lang="en-US"/>
               <a:t>Third level</a:t>
             </a:r>
           </a:p>
           <a:p>
             <a:pPr lvl="3"/>
             <a:r>
-              <a:rPr lang="en-US" smtClean="0"/>
+              <a:rPr lang="en-US"/>
               <a:t>Fourth level</a:t>
             </a:r>
           </a:p>
           <a:p>
             <a:pPr lvl="4"/>
             <a:r>
-              <a:rPr lang="en-US" smtClean="0"/>
+              <a:rPr lang="en-US"/>
               <a:t>Fifth level</a:t>
             </a:r>
-            <a:endParaRPr lang="en-US"/>
           </a:p>
         </p:txBody>
       </p:sp>
@@ -645,7 +655,7 @@
           <a:p>
             <a:fld id="{5BCAD085-E8A6-8845-BD4E-CB4CCA059FC4}" type="datetimeFigureOut">
               <a:rPr lang="en-US" smtClean="0"/>
-              <a:t>1/27/13</a:t>
+              <a:t>9/12/2026</a:t>
             </a:fld>
             <a:endParaRPr lang="en-US"/>
           </a:p>
@@ -739,10 +749,9 @@
           <a:lstStyle/>
           <a:p>
             <a:r>
-              <a:rPr lang="en-US" smtClean="0"/>
+              <a:rPr lang="en-US"/>
               <a:t>Click to edit Master title style</a:t>
             </a:r>
-            <a:endParaRPr lang="en-US"/>
           </a:p>
         </p:txBody>
       </p:sp>
@@ -763,38 +772,37 @@
           <a:p>
             <a:pPr lvl="0"/>
             <a:r>
-              <a:rPr lang="en-US" smtClean="0"/>
+              <a:rPr lang="en-US"/>
               <a:t>Click to edit Master text styles</a:t>
             </a:r>
           </a:p>
           <a:p>
             <a:pPr lvl="1"/>
             <a:r>
-              <a:rPr lang="en-US" smtClean="0"/>
+              <a:rPr lang="en-US"/>
               <a:t>Second level</a:t>
             </a:r>
           </a:p>
           <a:p>
             <a:pPr lvl="2"/>
             <a:r>
-              <a:rPr lang="en-US" smtClean="0"/>
+              <a:rPr lang="en-US"/>
               <a:t>Third level</a:t>
             </a:r>
           </a:p>
           <a:p>
             <a:pPr lvl="3"/>
             <a:r>
-              <a:rPr lang="en-US" smtClean="0"/>
+              <a:rPr lang="en-US"/>
               <a:t>Fourth level</a:t>
             </a:r>
           </a:p>
           <a:p>
             <a:pPr lvl="4"/>
             <a:r>
-              <a:rPr lang="en-US" smtClean="0"/>
+              <a:rPr lang="en-US"/>
               <a:t>Fifth level</a:t>
             </a:r>
-            <a:endParaRPr lang="en-US"/>
           </a:p>
         </p:txBody>
       </p:sp>
@@ -815,7 +823,7 @@
           <a:p>
             <a:fld id="{5BCAD085-E8A6-8845-BD4E-CB4CCA059FC4}" type="datetimeFigureOut">
               <a:rPr lang="en-US" smtClean="0"/>
-              <a:t>1/27/13</a:t>
+              <a:t>9/12/2026</a:t>
             </a:fld>
             <a:endParaRPr lang="en-US"/>
           </a:p>
@@ -918,10 +926,9 @@
           </a:lstStyle>
           <a:p>
             <a:r>
-              <a:rPr lang="en-US" smtClean="0"/>
+              <a:rPr lang="en-US"/>
               <a:t>Click to edit Master title style</a:t>
             </a:r>
-            <a:endParaRPr lang="en-US"/>
           </a:p>
         </p:txBody>
       </p:sp>
@@ -1038,7 +1045,7 @@
           <a:p>
             <a:pPr lvl="0"/>
             <a:r>
-              <a:rPr lang="en-US" smtClean="0"/>
+              <a:rPr lang="en-US"/>
               <a:t>Click to edit Master text styles</a:t>
             </a:r>
           </a:p>
@@ -1061,7 +1068,7 @@
           <a:p>
             <a:fld id="{5BCAD085-E8A6-8845-BD4E-CB4CCA059FC4}" type="datetimeFigureOut">
               <a:rPr lang="en-US" smtClean="0"/>
-              <a:t>1/27/13</a:t>
+              <a:t>9/12/2026</a:t>
             </a:fld>
             <a:endParaRPr lang="en-US"/>
           </a:p>
@@ -1155,10 +1162,9 @@
           <a:lstStyle/>
           <a:p>
             <a:r>
-              <a:rPr lang="en-US" smtClean="0"/>
+              <a:rPr lang="en-US"/>
               <a:t>Click to edit Master title style</a:t>
             </a:r>
-            <a:endParaRPr lang="en-US"/>
           </a:p>
         </p:txBody>
       </p:sp>
@@ -1212,38 +1218,37 @@
           <a:p>
             <a:pPr lvl="0"/>
             <a:r>
-              <a:rPr lang="en-US" smtClean="0"/>
+              <a:rPr lang="en-US"/>
               <a:t>Click to edit Master text styles</a:t>
             </a:r>
           </a:p>
           <a:p>
             <a:pPr lvl="1"/>
             <a:r>
-              <a:rPr lang="en-US" smtClean="0"/>
+              <a:rPr lang="en-US"/>
               <a:t>Second level</a:t>
             </a:r>
           </a:p>
           <a:p>
             <a:pPr lvl="2"/>
             <a:r>
-              <a:rPr lang="en-US" smtClean="0"/>
+              <a:rPr lang="en-US"/>
               <a:t>Third level</a:t>
             </a:r>
           </a:p>
           <a:p>
             <a:pPr lvl="3"/>
             <a:r>
-              <a:rPr lang="en-US" smtClean="0"/>
+              <a:rPr lang="en-US"/>
               <a:t>Fourth level</a:t>
             </a:r>
           </a:p>
           <a:p>
             <a:pPr lvl="4"/>
             <a:r>
-              <a:rPr lang="en-US" smtClean="0"/>
+              <a:rPr lang="en-US"/>
               <a:t>Fifth level</a:t>
             </a:r>
-            <a:endParaRPr lang="en-US"/>
           </a:p>
         </p:txBody>
       </p:sp>
@@ -1297,38 +1302,37 @@
           <a:p>
             <a:pPr lvl="0"/>
             <a:r>
-              <a:rPr lang="en-US" smtClean="0"/>
+              <a:rPr lang="en-US"/>
               <a:t>Click to edit Master text styles</a:t>
             </a:r>
           </a:p>
           <a:p>
             <a:pPr lvl="1"/>
             <a:r>
-              <a:rPr lang="en-US" smtClean="0"/>
+              <a:rPr lang="en-US"/>
               <a:t>Second level</a:t>
             </a:r>
           </a:p>
           <a:p>
             <a:pPr lvl="2"/>
             <a:r>
-              <a:rPr lang="en-US" smtClean="0"/>
+              <a:rPr lang="en-US"/>
               <a:t>Third level</a:t>
             </a:r>
           </a:p>
           <a:p>
             <a:pPr lvl="3"/>
             <a:r>
-              <a:rPr lang="en-US" smtClean="0"/>
+              <a:rPr lang="en-US"/>
               <a:t>Fourth level</a:t>
             </a:r>
           </a:p>
           <a:p>
             <a:pPr lvl="4"/>
             <a:r>
-              <a:rPr lang="en-US" smtClean="0"/>
+              <a:rPr lang="en-US"/>
               <a:t>Fifth level</a:t>
             </a:r>
-            <a:endParaRPr lang="en-US"/>
           </a:p>
         </p:txBody>
       </p:sp>
@@ -1349,7 +1353,7 @@
           <a:p>
             <a:fld id="{5BCAD085-E8A6-8845-BD4E-CB4CCA059FC4}" type="datetimeFigureOut">
               <a:rPr lang="en-US" smtClean="0"/>
-              <a:t>1/27/13</a:t>
+              <a:t>9/12/2026</a:t>
             </a:fld>
             <a:endParaRPr lang="en-US"/>
           </a:p>
@@ -1447,10 +1451,9 @@
           </a:lstStyle>
           <a:p>
             <a:r>
-              <a:rPr lang="en-US" smtClean="0"/>
+              <a:rPr lang="en-US"/>
               <a:t>Click to edit Master title style</a:t>
             </a:r>
-            <a:endParaRPr lang="en-US"/>
           </a:p>
         </p:txBody>
       </p:sp>
@@ -1513,7 +1516,7 @@
           <a:p>
             <a:pPr lvl="0"/>
             <a:r>
-              <a:rPr lang="en-US" smtClean="0"/>
+              <a:rPr lang="en-US"/>
               <a:t>Click to edit Master text styles</a:t>
             </a:r>
           </a:p>
@@ -1569,38 +1572,37 @@
           <a:p>
             <a:pPr lvl="0"/>
             <a:r>
-              <a:rPr lang="en-US" smtClean="0"/>
+              <a:rPr lang="en-US"/>
               <a:t>Click to edit Master text styles</a:t>
             </a:r>
           </a:p>
           <a:p>
             <a:pPr lvl="1"/>
             <a:r>
-              <a:rPr lang="en-US" smtClean="0"/>
+              <a:rPr lang="en-US"/>
               <a:t>Second level</a:t>
             </a:r>
           </a:p>
           <a:p>
             <a:pPr lvl="2"/>
             <a:r>
-              <a:rPr lang="en-US" smtClean="0"/>
+              <a:rPr lang="en-US"/>
               <a:t>Third level</a:t>
             </a:r>
           </a:p>
           <a:p>
             <a:pPr lvl="3"/>
             <a:r>
-              <a:rPr lang="en-US" smtClean="0"/>
+              <a:rPr lang="en-US"/>
               <a:t>Fourth level</a:t>
             </a:r>
           </a:p>
           <a:p>
             <a:pPr lvl="4"/>
             <a:r>
-              <a:rPr lang="en-US" smtClean="0"/>
+              <a:rPr lang="en-US"/>
               <a:t>Fifth level</a:t>
             </a:r>
-            <a:endParaRPr lang="en-US"/>
           </a:p>
         </p:txBody>
       </p:sp>
@@ -1663,7 +1665,7 @@
           <a:p>
             <a:pPr lvl="0"/>
             <a:r>
-              <a:rPr lang="en-US" smtClean="0"/>
+              <a:rPr lang="en-US"/>
               <a:t>Click to edit Master text styles</a:t>
             </a:r>
           </a:p>
@@ -1719,38 +1721,37 @@
           <a:p>
             <a:pPr lvl="0"/>
             <a:r>
-              <a:rPr lang="en-US" smtClean="0"/>
+              <a:rPr lang="en-US"/>
               <a:t>Click to edit Master text styles</a:t>
             </a:r>
           </a:p>
           <a:p>
             <a:pPr lvl="1"/>
             <a:r>
-              <a:rPr lang="en-US" smtClean="0"/>
+              <a:rPr lang="en-US"/>
               <a:t>Second level</a:t>
             </a:r>
           </a:p>
           <a:p>
             <a:pPr lvl="2"/>
             <a:r>
-              <a:rPr lang="en-US" smtClean="0"/>
+              <a:rPr lang="en-US"/>
               <a:t>Third level</a:t>
             </a:r>
           </a:p>
           <a:p>
             <a:pPr lvl="3"/>
             <a:r>
-              <a:rPr lang="en-US" smtClean="0"/>
+              <a:rPr lang="en-US"/>
               <a:t>Fourth level</a:t>
             </a:r>
           </a:p>
           <a:p>
             <a:pPr lvl="4"/>
             <a:r>
-              <a:rPr lang="en-US" smtClean="0"/>
+              <a:rPr lang="en-US"/>
               <a:t>Fifth level</a:t>
             </a:r>
-            <a:endParaRPr lang="en-US"/>
           </a:p>
         </p:txBody>
       </p:sp>
@@ -1771,7 +1772,7 @@
           <a:p>
             <a:fld id="{5BCAD085-E8A6-8845-BD4E-CB4CCA059FC4}" type="datetimeFigureOut">
               <a:rPr lang="en-US" smtClean="0"/>
-              <a:t>1/27/13</a:t>
+              <a:t>9/12/2026</a:t>
             </a:fld>
             <a:endParaRPr lang="en-US"/>
           </a:p>
@@ -1865,10 +1866,9 @@
           <a:lstStyle/>
           <a:p>
             <a:r>
-              <a:rPr lang="en-US" smtClean="0"/>
+              <a:rPr lang="en-US"/>
               <a:t>Click to edit Master title style</a:t>
             </a:r>
-            <a:endParaRPr lang="en-US"/>
           </a:p>
         </p:txBody>
       </p:sp>
@@ -1889,7 +1889,7 @@
           <a:p>
             <a:fld id="{5BCAD085-E8A6-8845-BD4E-CB4CCA059FC4}" type="datetimeFigureOut">
               <a:rPr lang="en-US" smtClean="0"/>
-              <a:t>1/27/13</a:t>
+              <a:t>9/12/2026</a:t>
             </a:fld>
             <a:endParaRPr lang="en-US"/>
           </a:p>
@@ -1984,7 +1984,7 @@
           <a:p>
             <a:fld id="{5BCAD085-E8A6-8845-BD4E-CB4CCA059FC4}" type="datetimeFigureOut">
               <a:rPr lang="en-US" smtClean="0"/>
-              <a:t>1/27/13</a:t>
+              <a:t>9/12/2026</a:t>
             </a:fld>
             <a:endParaRPr lang="en-US"/>
           </a:p>
@@ -2087,10 +2087,9 @@
           </a:lstStyle>
           <a:p>
             <a:r>
-              <a:rPr lang="en-US" smtClean="0"/>
+              <a:rPr lang="en-US"/>
               <a:t>Click to edit Master title style</a:t>
             </a:r>
-            <a:endParaRPr lang="en-US"/>
           </a:p>
         </p:txBody>
       </p:sp>
@@ -2144,38 +2143,37 @@
           <a:p>
             <a:pPr lvl="0"/>
             <a:r>
-              <a:rPr lang="en-US" smtClean="0"/>
+              <a:rPr lang="en-US"/>
               <a:t>Click to edit Master text styles</a:t>
             </a:r>
           </a:p>
           <a:p>
             <a:pPr lvl="1"/>
             <a:r>
-              <a:rPr lang="en-US" smtClean="0"/>
+              <a:rPr lang="en-US"/>
               <a:t>Second level</a:t>
             </a:r>
           </a:p>
           <a:p>
             <a:pPr lvl="2"/>
             <a:r>
-              <a:rPr lang="en-US" smtClean="0"/>
+              <a:rPr lang="en-US"/>
               <a:t>Third level</a:t>
             </a:r>
           </a:p>
           <a:p>
             <a:pPr lvl="3"/>
             <a:r>
-              <a:rPr lang="en-US" smtClean="0"/>
+              <a:rPr lang="en-US"/>
               <a:t>Fourth level</a:t>
             </a:r>
           </a:p>
           <a:p>
             <a:pPr lvl="4"/>
             <a:r>
-              <a:rPr lang="en-US" smtClean="0"/>
+              <a:rPr lang="en-US"/>
               <a:t>Fifth level</a:t>
             </a:r>
-            <a:endParaRPr lang="en-US"/>
           </a:p>
         </p:txBody>
       </p:sp>
@@ -2238,7 +2236,7 @@
           <a:p>
             <a:pPr lvl="0"/>
             <a:r>
-              <a:rPr lang="en-US" smtClean="0"/>
+              <a:rPr lang="en-US"/>
               <a:t>Click to edit Master text styles</a:t>
             </a:r>
           </a:p>
@@ -2261,7 +2259,7 @@
           <a:p>
             <a:fld id="{5BCAD085-E8A6-8845-BD4E-CB4CCA059FC4}" type="datetimeFigureOut">
               <a:rPr lang="en-US" smtClean="0"/>
-              <a:t>1/27/13</a:t>
+              <a:t>9/12/2026</a:t>
             </a:fld>
             <a:endParaRPr lang="en-US"/>
           </a:p>
@@ -2364,10 +2362,9 @@
           </a:lstStyle>
           <a:p>
             <a:r>
-              <a:rPr lang="en-US" smtClean="0"/>
+              <a:rPr lang="en-US"/>
               <a:t>Click to edit Master title style</a:t>
             </a:r>
-            <a:endParaRPr lang="en-US"/>
           </a:p>
         </p:txBody>
       </p:sp>
@@ -2491,7 +2488,7 @@
           <a:p>
             <a:pPr lvl="0"/>
             <a:r>
-              <a:rPr lang="en-US" smtClean="0"/>
+              <a:rPr lang="en-US"/>
               <a:t>Click to edit Master text styles</a:t>
             </a:r>
           </a:p>
@@ -2514,7 +2511,7 @@
           <a:p>
             <a:fld id="{5BCAD085-E8A6-8845-BD4E-CB4CCA059FC4}" type="datetimeFigureOut">
               <a:rPr lang="en-US" smtClean="0"/>
-              <a:t>1/27/13</a:t>
+              <a:t>9/12/2026</a:t>
             </a:fld>
             <a:endParaRPr lang="en-US"/>
           </a:p>
@@ -2623,10 +2620,9 @@
           <a:lstStyle/>
           <a:p>
             <a:r>
-              <a:rPr lang="en-US" smtClean="0"/>
+              <a:rPr lang="en-US"/>
               <a:t>Click to edit Master title style</a:t>
             </a:r>
-            <a:endParaRPr lang="en-US"/>
           </a:p>
         </p:txBody>
       </p:sp>
@@ -2657,38 +2653,37 @@
           <a:p>
             <a:pPr lvl="0"/>
             <a:r>
-              <a:rPr lang="en-US" smtClean="0"/>
+              <a:rPr lang="en-US"/>
               <a:t>Click to edit Master text styles</a:t>
             </a:r>
           </a:p>
           <a:p>
             <a:pPr lvl="1"/>
             <a:r>
-              <a:rPr lang="en-US" smtClean="0"/>
+              <a:rPr lang="en-US"/>
               <a:t>Second level</a:t>
             </a:r>
           </a:p>
           <a:p>
             <a:pPr lvl="2"/>
             <a:r>
-              <a:rPr lang="en-US" smtClean="0"/>
+              <a:rPr lang="en-US"/>
               <a:t>Third level</a:t>
             </a:r>
           </a:p>
           <a:p>
             <a:pPr lvl="3"/>
             <a:r>
-              <a:rPr lang="en-US" smtClean="0"/>
+              <a:rPr lang="en-US"/>
               <a:t>Fourth level</a:t>
             </a:r>
           </a:p>
           <a:p>
             <a:pPr lvl="4"/>
             <a:r>
-              <a:rPr lang="en-US" smtClean="0"/>
+              <a:rPr lang="en-US"/>
               <a:t>Fifth level</a:t>
             </a:r>
-            <a:endParaRPr lang="en-US"/>
           </a:p>
         </p:txBody>
       </p:sp>
@@ -2727,7 +2722,7 @@
           <a:p>
             <a:fld id="{5BCAD085-E8A6-8845-BD4E-CB4CCA059FC4}" type="datetimeFigureOut">
               <a:rPr lang="en-US" smtClean="0"/>
-              <a:t>1/27/13</a:t>
+              <a:t>9/12/2026</a:t>
             </a:fld>
             <a:endParaRPr lang="en-US"/>
           </a:p>
@@ -3086,7 +3081,7 @@
 </file>
 
 <file path=ppt/slides/slide1.xml><?xml version="1.0" encoding="utf-8"?>
-<p:sld xmlns:a="http://schemas.openxmlformats.org/drawingml/2006/main" xmlns:p="http://schemas.openxmlformats.org/presentationml/2006/main" xmlns:r="http://schemas.openxmlformats.org/officeDocument/2006/relationships">
+<p:sld xmlns:a="http://schemas.openxmlformats.org/drawingml/2006/main" xmlns:r="http://schemas.openxmlformats.org/officeDocument/2006/relationships" xmlns:p="http://schemas.openxmlformats.org/presentationml/2006/main">
   <p:cSld>
     <p:bg>
       <p:bgPr>
@@ -3102,7 +3097,14 @@
         <p:cNvGrpSpPr/>
         <p:nvPr/>
       </p:nvGrpSpPr>
-      <p:grpSpPr/>
+      <p:grpSpPr>
+        <a:xfrm>
+          <a:off x="0" y="0"/>
+          <a:ext cx="0" cy="0"/>
+          <a:chOff x="0" y="0"/>
+          <a:chExt cx="0" cy="0"/>
+        </a:xfrm>
+      </p:grpSpPr>
       <p:sp>
         <p:nvSpPr>
           <p:cNvPr id="2" name="TextBox 1"/>
@@ -3203,7 +3205,7 @@
 </file>
 
 <file path=ppt/slides/slide2.xml><?xml version="1.0" encoding="utf-8"?>
-<p:sld xmlns:a="http://schemas.openxmlformats.org/drawingml/2006/main" xmlns:p="http://schemas.openxmlformats.org/presentationml/2006/main" xmlns:r="http://schemas.openxmlformats.org/officeDocument/2006/relationships">
+<p:sld xmlns:a="http://schemas.openxmlformats.org/drawingml/2006/main" xmlns:r="http://schemas.openxmlformats.org/officeDocument/2006/relationships" xmlns:p="http://schemas.openxmlformats.org/presentationml/2006/main">
   <p:cSld>
     <p:bg>
       <p:bgPr>
@@ -3219,7 +3221,14 @@
         <p:cNvGrpSpPr/>
         <p:nvPr/>
       </p:nvGrpSpPr>
-      <p:grpSpPr/>
+      <p:grpSpPr>
+        <a:xfrm>
+          <a:off x="0" y="0"/>
+          <a:ext cx="0" cy="0"/>
+          <a:chOff x="0" y="0"/>
+          <a:chExt cx="0" cy="0"/>
+        </a:xfrm>
+      </p:grpSpPr>
       <p:sp>
         <p:nvSpPr>
           <p:cNvPr id="2" name="TextBox 1"/>
@@ -3303,6 +3312,7 @@
           <a:lstStyle/>
           <a:p>
             <a:pPr algn="ctr"/>
+            <a:endParaRPr/>
           </a:p>
         </p:txBody>
       </p:sp>
@@ -3393,11 +3403,41 @@
                 <a:tableStyleId>{5C22544A-7EE6-4342-B048-85BDC9FD1C3A}</a:tableStyleId>
               </a:tblPr>
               <a:tblGrid>
-                <a:gridCol w="640079"/>
-                <a:gridCol w="2377440"/>
-                <a:gridCol w="2743200"/>
-                <a:gridCol w="3291840"/>
-                <a:gridCol w="2194559"/>
+                <a:gridCol w="640079">
+                  <a:extLst>
+                    <a:ext uri="{9D8B030D-6E8A-4147-A177-3AD203B41FA5}">
+                      <a16:colId xmlns:a16="http://schemas.microsoft.com/office/drawing/2014/main" val="20000"/>
+                    </a:ext>
+                  </a:extLst>
+                </a:gridCol>
+                <a:gridCol w="2377440">
+                  <a:extLst>
+                    <a:ext uri="{9D8B030D-6E8A-4147-A177-3AD203B41FA5}">
+                      <a16:colId xmlns:a16="http://schemas.microsoft.com/office/drawing/2014/main" val="20001"/>
+                    </a:ext>
+                  </a:extLst>
+                </a:gridCol>
+                <a:gridCol w="2743200">
+                  <a:extLst>
+                    <a:ext uri="{9D8B030D-6E8A-4147-A177-3AD203B41FA5}">
+                      <a16:colId xmlns:a16="http://schemas.microsoft.com/office/drawing/2014/main" val="20002"/>
+                    </a:ext>
+                  </a:extLst>
+                </a:gridCol>
+                <a:gridCol w="3291840">
+                  <a:extLst>
+                    <a:ext uri="{9D8B030D-6E8A-4147-A177-3AD203B41FA5}">
+                      <a16:colId xmlns:a16="http://schemas.microsoft.com/office/drawing/2014/main" val="20003"/>
+                    </a:ext>
+                  </a:extLst>
+                </a:gridCol>
+                <a:gridCol w="2194559">
+                  <a:extLst>
+                    <a:ext uri="{9D8B030D-6E8A-4147-A177-3AD203B41FA5}">
+                      <a16:colId xmlns:a16="http://schemas.microsoft.com/office/drawing/2014/main" val="20004"/>
+                    </a:ext>
+                  </a:extLst>
+                </a:gridCol>
               </a:tblGrid>
               <a:tr h="713232">
                 <a:tc>
@@ -3510,6 +3550,11 @@
                     </a:solidFill>
                   </a:tcPr>
                 </a:tc>
+                <a:extLst>
+                  <a:ext uri="{0D108BD9-81ED-4DB2-BD59-A6C34878D82A}">
+                    <a16:rowId xmlns:a16="http://schemas.microsoft.com/office/drawing/2014/main" val="10000"/>
+                  </a:ext>
+                </a:extLst>
               </a:tr>
               <a:tr h="713232">
                 <a:tc>
@@ -3657,6 +3702,11 @@
                     </a:solidFill>
                   </a:tcPr>
                 </a:tc>
+                <a:extLst>
+                  <a:ext uri="{0D108BD9-81ED-4DB2-BD59-A6C34878D82A}">
+                    <a16:rowId xmlns:a16="http://schemas.microsoft.com/office/drawing/2014/main" val="10001"/>
+                  </a:ext>
+                </a:extLst>
               </a:tr>
               <a:tr h="713232">
                 <a:tc>
@@ -3794,6 +3844,11 @@
                     </a:solidFill>
                   </a:tcPr>
                 </a:tc>
+                <a:extLst>
+                  <a:ext uri="{0D108BD9-81ED-4DB2-BD59-A6C34878D82A}">
+                    <a16:rowId xmlns:a16="http://schemas.microsoft.com/office/drawing/2014/main" val="10002"/>
+                  </a:ext>
+                </a:extLst>
               </a:tr>
               <a:tr h="713232">
                 <a:tc>
@@ -3931,6 +3986,11 @@
                     </a:solidFill>
                   </a:tcPr>
                 </a:tc>
+                <a:extLst>
+                  <a:ext uri="{0D108BD9-81ED-4DB2-BD59-A6C34878D82A}">
+                    <a16:rowId xmlns:a16="http://schemas.microsoft.com/office/drawing/2014/main" val="10003"/>
+                  </a:ext>
+                </a:extLst>
               </a:tr>
               <a:tr h="713232">
                 <a:tc>
@@ -4038,6 +4098,11 @@
                     </a:solidFill>
                   </a:tcPr>
                 </a:tc>
+                <a:extLst>
+                  <a:ext uri="{0D108BD9-81ED-4DB2-BD59-A6C34878D82A}">
+                    <a16:rowId xmlns:a16="http://schemas.microsoft.com/office/drawing/2014/main" val="10004"/>
+                  </a:ext>
+                </a:extLst>
               </a:tr>
             </a:tbl>
           </a:graphicData>
@@ -4085,7 +4150,7 @@
 </file>
 
 <file path=ppt/slides/slide3.xml><?xml version="1.0" encoding="utf-8"?>
-<p:sld xmlns:a="http://schemas.openxmlformats.org/drawingml/2006/main" xmlns:p="http://schemas.openxmlformats.org/presentationml/2006/main" xmlns:r="http://schemas.openxmlformats.org/officeDocument/2006/relationships">
+<p:sld xmlns:a="http://schemas.openxmlformats.org/drawingml/2006/main" xmlns:r="http://schemas.openxmlformats.org/officeDocument/2006/relationships" xmlns:p="http://schemas.openxmlformats.org/presentationml/2006/main">
   <p:cSld>
     <p:bg>
       <p:bgPr>
@@ -4101,7 +4166,14 @@
         <p:cNvGrpSpPr/>
         <p:nvPr/>
       </p:nvGrpSpPr>
-      <p:grpSpPr/>
+      <p:grpSpPr>
+        <a:xfrm>
+          <a:off x="0" y="0"/>
+          <a:ext cx="0" cy="0"/>
+          <a:chOff x="0" y="0"/>
+          <a:chExt cx="0" cy="0"/>
+        </a:xfrm>
+      </p:grpSpPr>
       <p:sp>
         <p:nvSpPr>
           <p:cNvPr id="2" name="TextBox 1"/>
@@ -4185,6 +4257,7 @@
           <a:lstStyle/>
           <a:p>
             <a:pPr algn="ctr"/>
+            <a:endParaRPr/>
           </a:p>
         </p:txBody>
       </p:sp>
@@ -4370,7 +4443,7 @@
 </file>
 
 <file path=ppt/slides/slide4.xml><?xml version="1.0" encoding="utf-8"?>
-<p:sld xmlns:a="http://schemas.openxmlformats.org/drawingml/2006/main" xmlns:p="http://schemas.openxmlformats.org/presentationml/2006/main" xmlns:r="http://schemas.openxmlformats.org/officeDocument/2006/relationships">
+<p:sld xmlns:a="http://schemas.openxmlformats.org/drawingml/2006/main" xmlns:r="http://schemas.openxmlformats.org/officeDocument/2006/relationships" xmlns:p="http://schemas.openxmlformats.org/presentationml/2006/main">
   <p:cSld>
     <p:bg>
       <p:bgPr>
@@ -4386,7 +4459,14 @@
         <p:cNvGrpSpPr/>
         <p:nvPr/>
       </p:nvGrpSpPr>
-      <p:grpSpPr/>
+      <p:grpSpPr>
+        <a:xfrm>
+          <a:off x="0" y="0"/>
+          <a:ext cx="0" cy="0"/>
+          <a:chOff x="0" y="0"/>
+          <a:chExt cx="0" cy="0"/>
+        </a:xfrm>
+      </p:grpSpPr>
       <p:sp>
         <p:nvSpPr>
           <p:cNvPr id="2" name="TextBox 1"/>
@@ -4470,6 +4550,7 @@
           <a:lstStyle/>
           <a:p>
             <a:pPr algn="ctr"/>
+            <a:endParaRPr/>
           </a:p>
         </p:txBody>
       </p:sp>
@@ -4670,7 +4751,7 @@
 </file>
 
 <file path=ppt/slides/slide5.xml><?xml version="1.0" encoding="utf-8"?>
-<p:sld xmlns:a="http://schemas.openxmlformats.org/drawingml/2006/main" xmlns:p="http://schemas.openxmlformats.org/presentationml/2006/main" xmlns:r="http://schemas.openxmlformats.org/officeDocument/2006/relationships">
+<p:sld xmlns:a="http://schemas.openxmlformats.org/drawingml/2006/main" xmlns:r="http://schemas.openxmlformats.org/officeDocument/2006/relationships" xmlns:p="http://schemas.openxmlformats.org/presentationml/2006/main">
   <p:cSld>
     <p:bg>
       <p:bgPr>
@@ -4686,7 +4767,14 @@
         <p:cNvGrpSpPr/>
         <p:nvPr/>
       </p:nvGrpSpPr>
-      <p:grpSpPr/>
+      <p:grpSpPr>
+        <a:xfrm>
+          <a:off x="0" y="0"/>
+          <a:ext cx="0" cy="0"/>
+          <a:chOff x="0" y="0"/>
+          <a:chExt cx="0" cy="0"/>
+        </a:xfrm>
+      </p:grpSpPr>
       <p:sp>
         <p:nvSpPr>
           <p:cNvPr id="2" name="TextBox 1"/>
@@ -4770,6 +4858,7 @@
           <a:lstStyle/>
           <a:p>
             <a:pPr algn="ctr"/>
+            <a:endParaRPr/>
           </a:p>
         </p:txBody>
       </p:sp>
@@ -4979,7 +5068,7 @@
 </file>
 
 <file path=ppt/slides/slide6.xml><?xml version="1.0" encoding="utf-8"?>
-<p:sld xmlns:a="http://schemas.openxmlformats.org/drawingml/2006/main" xmlns:p="http://schemas.openxmlformats.org/presentationml/2006/main" xmlns:r="http://schemas.openxmlformats.org/officeDocument/2006/relationships">
+<p:sld xmlns:a="http://schemas.openxmlformats.org/drawingml/2006/main" xmlns:r="http://schemas.openxmlformats.org/officeDocument/2006/relationships" xmlns:p="http://schemas.openxmlformats.org/presentationml/2006/main">
   <p:cSld>
     <p:bg>
       <p:bgPr>
@@ -4995,7 +5084,14 @@
         <p:cNvGrpSpPr/>
         <p:nvPr/>
       </p:nvGrpSpPr>
-      <p:grpSpPr/>
+      <p:grpSpPr>
+        <a:xfrm>
+          <a:off x="0" y="0"/>
+          <a:ext cx="0" cy="0"/>
+          <a:chOff x="0" y="0"/>
+          <a:chExt cx="0" cy="0"/>
+        </a:xfrm>
+      </p:grpSpPr>
       <p:sp>
         <p:nvSpPr>
           <p:cNvPr id="2" name="TextBox 1"/>
@@ -5079,6 +5175,7 @@
           <a:lstStyle/>
           <a:p>
             <a:pPr algn="ctr"/>
+            <a:endParaRPr/>
           </a:p>
         </p:txBody>
       </p:sp>
@@ -5101,10 +5198,34 @@
                 <a:tableStyleId>{5C22544A-7EE6-4342-B048-85BDC9FD1C3A}</a:tableStyleId>
               </a:tblPr>
               <a:tblGrid>
-                <a:gridCol w="1188720"/>
-                <a:gridCol w="3383280"/>
-                <a:gridCol w="3383280"/>
-                <a:gridCol w="3474720"/>
+                <a:gridCol w="1188720">
+                  <a:extLst>
+                    <a:ext uri="{9D8B030D-6E8A-4147-A177-3AD203B41FA5}">
+                      <a16:colId xmlns:a16="http://schemas.microsoft.com/office/drawing/2014/main" val="20000"/>
+                    </a:ext>
+                  </a:extLst>
+                </a:gridCol>
+                <a:gridCol w="3383280">
+                  <a:extLst>
+                    <a:ext uri="{9D8B030D-6E8A-4147-A177-3AD203B41FA5}">
+                      <a16:colId xmlns:a16="http://schemas.microsoft.com/office/drawing/2014/main" val="20001"/>
+                    </a:ext>
+                  </a:extLst>
+                </a:gridCol>
+                <a:gridCol w="3383280">
+                  <a:extLst>
+                    <a:ext uri="{9D8B030D-6E8A-4147-A177-3AD203B41FA5}">
+                      <a16:colId xmlns:a16="http://schemas.microsoft.com/office/drawing/2014/main" val="20002"/>
+                    </a:ext>
+                  </a:extLst>
+                </a:gridCol>
+                <a:gridCol w="3474720">
+                  <a:extLst>
+                    <a:ext uri="{9D8B030D-6E8A-4147-A177-3AD203B41FA5}">
+                      <a16:colId xmlns:a16="http://schemas.microsoft.com/office/drawing/2014/main" val="20003"/>
+                    </a:ext>
+                  </a:extLst>
+                </a:gridCol>
               </a:tblGrid>
               <a:tr h="1024128">
                 <a:tc>
@@ -5113,6 +5234,7 @@
                     <a:lstStyle/>
                     <a:p>
                       <a:pPr algn="ctr"/>
+                      <a:endParaRPr/>
                     </a:p>
                   </a:txBody>
                   <a:tcPr anchor="ctr">
@@ -5187,6 +5309,11 @@
                     </a:solidFill>
                   </a:tcPr>
                 </a:tc>
+                <a:extLst>
+                  <a:ext uri="{0D108BD9-81ED-4DB2-BD59-A6C34878D82A}">
+                    <a16:rowId xmlns:a16="http://schemas.microsoft.com/office/drawing/2014/main" val="10000"/>
+                  </a:ext>
+                </a:extLst>
               </a:tr>
               <a:tr h="1024128">
                 <a:tc>
@@ -5273,6 +5400,11 @@
                     </a:solidFill>
                   </a:tcPr>
                 </a:tc>
+                <a:extLst>
+                  <a:ext uri="{0D108BD9-81ED-4DB2-BD59-A6C34878D82A}">
+                    <a16:rowId xmlns:a16="http://schemas.microsoft.com/office/drawing/2014/main" val="10001"/>
+                  </a:ext>
+                </a:extLst>
               </a:tr>
               <a:tr h="1024128">
                 <a:tc>
@@ -5369,6 +5501,11 @@
                     </a:solidFill>
                   </a:tcPr>
                 </a:tc>
+                <a:extLst>
+                  <a:ext uri="{0D108BD9-81ED-4DB2-BD59-A6C34878D82A}">
+                    <a16:rowId xmlns:a16="http://schemas.microsoft.com/office/drawing/2014/main" val="10002"/>
+                  </a:ext>
+                </a:extLst>
               </a:tr>
               <a:tr h="1024128">
                 <a:tc>
@@ -5455,6 +5592,11 @@
                     </a:solidFill>
                   </a:tcPr>
                 </a:tc>
+                <a:extLst>
+                  <a:ext uri="{0D108BD9-81ED-4DB2-BD59-A6C34878D82A}">
+                    <a16:rowId xmlns:a16="http://schemas.microsoft.com/office/drawing/2014/main" val="10003"/>
+                  </a:ext>
+                </a:extLst>
               </a:tr>
               <a:tr h="1024128">
                 <a:tc>
@@ -5541,6 +5683,11 @@
                     </a:solidFill>
                   </a:tcPr>
                 </a:tc>
+                <a:extLst>
+                  <a:ext uri="{0D108BD9-81ED-4DB2-BD59-A6C34878D82A}">
+                    <a16:rowId xmlns:a16="http://schemas.microsoft.com/office/drawing/2014/main" val="10004"/>
+                  </a:ext>
+                </a:extLst>
               </a:tr>
             </a:tbl>
           </a:graphicData>
@@ -5588,7 +5735,7 @@
 </file>
 
 <file path=ppt/slides/slide7.xml><?xml version="1.0" encoding="utf-8"?>
-<p:sld xmlns:a="http://schemas.openxmlformats.org/drawingml/2006/main" xmlns:p="http://schemas.openxmlformats.org/presentationml/2006/main" xmlns:r="http://schemas.openxmlformats.org/officeDocument/2006/relationships">
+<p:sld xmlns:a="http://schemas.openxmlformats.org/drawingml/2006/main" xmlns:r="http://schemas.openxmlformats.org/officeDocument/2006/relationships" xmlns:p="http://schemas.openxmlformats.org/presentationml/2006/main">
   <p:cSld>
     <p:bg>
       <p:bgPr>
@@ -5604,7 +5751,14 @@
         <p:cNvGrpSpPr/>
         <p:nvPr/>
       </p:nvGrpSpPr>
-      <p:grpSpPr/>
+      <p:grpSpPr>
+        <a:xfrm>
+          <a:off x="0" y="0"/>
+          <a:ext cx="0" cy="0"/>
+          <a:chOff x="0" y="0"/>
+          <a:chExt cx="0" cy="0"/>
+        </a:xfrm>
+      </p:grpSpPr>
       <p:sp>
         <p:nvSpPr>
           <p:cNvPr id="2" name="TextBox 1"/>
@@ -5688,6 +5842,7 @@
           <a:lstStyle/>
           <a:p>
             <a:pPr algn="ctr"/>
+            <a:endParaRPr/>
           </a:p>
         </p:txBody>
       </p:sp>
@@ -5710,9 +5865,27 @@
                 <a:tableStyleId>{5C22544A-7EE6-4342-B048-85BDC9FD1C3A}</a:tableStyleId>
               </a:tblPr>
               <a:tblGrid>
-                <a:gridCol w="1463040"/>
-                <a:gridCol w="5943600"/>
-                <a:gridCol w="4023360"/>
+                <a:gridCol w="1463040">
+                  <a:extLst>
+                    <a:ext uri="{9D8B030D-6E8A-4147-A177-3AD203B41FA5}">
+                      <a16:colId xmlns:a16="http://schemas.microsoft.com/office/drawing/2014/main" val="20000"/>
+                    </a:ext>
+                  </a:extLst>
+                </a:gridCol>
+                <a:gridCol w="5943600">
+                  <a:extLst>
+                    <a:ext uri="{9D8B030D-6E8A-4147-A177-3AD203B41FA5}">
+                      <a16:colId xmlns:a16="http://schemas.microsoft.com/office/drawing/2014/main" val="20001"/>
+                    </a:ext>
+                  </a:extLst>
+                </a:gridCol>
+                <a:gridCol w="4023360">
+                  <a:extLst>
+                    <a:ext uri="{9D8B030D-6E8A-4147-A177-3AD203B41FA5}">
+                      <a16:colId xmlns:a16="http://schemas.microsoft.com/office/drawing/2014/main" val="20002"/>
+                    </a:ext>
+                  </a:extLst>
+                </a:gridCol>
               </a:tblGrid>
               <a:tr h="512064">
                 <a:tc>
@@ -5781,6 +5954,11 @@
                     </a:solidFill>
                   </a:tcPr>
                 </a:tc>
+                <a:extLst>
+                  <a:ext uri="{0D108BD9-81ED-4DB2-BD59-A6C34878D82A}">
+                    <a16:rowId xmlns:a16="http://schemas.microsoft.com/office/drawing/2014/main" val="10000"/>
+                  </a:ext>
+                </a:extLst>
               </a:tr>
               <a:tr h="512064">
                 <a:tc>
@@ -5846,6 +6024,11 @@
                     </a:solidFill>
                   </a:tcPr>
                 </a:tc>
+                <a:extLst>
+                  <a:ext uri="{0D108BD9-81ED-4DB2-BD59-A6C34878D82A}">
+                    <a16:rowId xmlns:a16="http://schemas.microsoft.com/office/drawing/2014/main" val="10001"/>
+                  </a:ext>
+                </a:extLst>
               </a:tr>
               <a:tr h="512064">
                 <a:tc>
@@ -5911,6 +6094,11 @@
                     </a:solidFill>
                   </a:tcPr>
                 </a:tc>
+                <a:extLst>
+                  <a:ext uri="{0D108BD9-81ED-4DB2-BD59-A6C34878D82A}">
+                    <a16:rowId xmlns:a16="http://schemas.microsoft.com/office/drawing/2014/main" val="10002"/>
+                  </a:ext>
+                </a:extLst>
               </a:tr>
               <a:tr h="512064">
                 <a:tc>
@@ -5976,6 +6164,11 @@
                     </a:solidFill>
                   </a:tcPr>
                 </a:tc>
+                <a:extLst>
+                  <a:ext uri="{0D108BD9-81ED-4DB2-BD59-A6C34878D82A}">
+                    <a16:rowId xmlns:a16="http://schemas.microsoft.com/office/drawing/2014/main" val="10003"/>
+                  </a:ext>
+                </a:extLst>
               </a:tr>
               <a:tr h="512064">
                 <a:tc>
@@ -6041,6 +6234,11 @@
                     </a:solidFill>
                   </a:tcPr>
                 </a:tc>
+                <a:extLst>
+                  <a:ext uri="{0D108BD9-81ED-4DB2-BD59-A6C34878D82A}">
+                    <a16:rowId xmlns:a16="http://schemas.microsoft.com/office/drawing/2014/main" val="10004"/>
+                  </a:ext>
+                </a:extLst>
               </a:tr>
               <a:tr h="512064">
                 <a:tc>
@@ -6106,6 +6304,11 @@
                     </a:solidFill>
                   </a:tcPr>
                 </a:tc>
+                <a:extLst>
+                  <a:ext uri="{0D108BD9-81ED-4DB2-BD59-A6C34878D82A}">
+                    <a16:rowId xmlns:a16="http://schemas.microsoft.com/office/drawing/2014/main" val="10005"/>
+                  </a:ext>
+                </a:extLst>
               </a:tr>
               <a:tr h="512064">
                 <a:tc>
@@ -6171,6 +6374,11 @@
                     </a:solidFill>
                   </a:tcPr>
                 </a:tc>
+                <a:extLst>
+                  <a:ext uri="{0D108BD9-81ED-4DB2-BD59-A6C34878D82A}">
+                    <a16:rowId xmlns:a16="http://schemas.microsoft.com/office/drawing/2014/main" val="10006"/>
+                  </a:ext>
+                </a:extLst>
               </a:tr>
               <a:tr h="512064">
                 <a:tc>
@@ -6236,6 +6444,11 @@
                     </a:solidFill>
                   </a:tcPr>
                 </a:tc>
+                <a:extLst>
+                  <a:ext uri="{0D108BD9-81ED-4DB2-BD59-A6C34878D82A}">
+                    <a16:rowId xmlns:a16="http://schemas.microsoft.com/office/drawing/2014/main" val="10007"/>
+                  </a:ext>
+                </a:extLst>
               </a:tr>
               <a:tr h="512064">
                 <a:tc>
@@ -6301,6 +6514,11 @@
                     </a:solidFill>
                   </a:tcPr>
                 </a:tc>
+                <a:extLst>
+                  <a:ext uri="{0D108BD9-81ED-4DB2-BD59-A6C34878D82A}">
+                    <a16:rowId xmlns:a16="http://schemas.microsoft.com/office/drawing/2014/main" val="10008"/>
+                  </a:ext>
+                </a:extLst>
               </a:tr>
               <a:tr h="512064">
                 <a:tc>
@@ -6366,6 +6584,11 @@
                     </a:solidFill>
                   </a:tcPr>
                 </a:tc>
+                <a:extLst>
+                  <a:ext uri="{0D108BD9-81ED-4DB2-BD59-A6C34878D82A}">
+                    <a16:rowId xmlns:a16="http://schemas.microsoft.com/office/drawing/2014/main" val="10009"/>
+                  </a:ext>
+                </a:extLst>
               </a:tr>
             </a:tbl>
           </a:graphicData>
@@ -6413,7 +6636,7 @@
 </file>
 
 <file path=ppt/slides/slide8.xml><?xml version="1.0" encoding="utf-8"?>
-<p:sld xmlns:a="http://schemas.openxmlformats.org/drawingml/2006/main" xmlns:p="http://schemas.openxmlformats.org/presentationml/2006/main" xmlns:r="http://schemas.openxmlformats.org/officeDocument/2006/relationships">
+<p:sld xmlns:a="http://schemas.openxmlformats.org/drawingml/2006/main" xmlns:r="http://schemas.openxmlformats.org/officeDocument/2006/relationships" xmlns:p="http://schemas.openxmlformats.org/presentationml/2006/main">
   <p:cSld>
     <p:bg>
       <p:bgPr>
@@ -6429,7 +6652,14 @@
         <p:cNvGrpSpPr/>
         <p:nvPr/>
       </p:nvGrpSpPr>
-      <p:grpSpPr/>
+      <p:grpSpPr>
+        <a:xfrm>
+          <a:off x="0" y="0"/>
+          <a:ext cx="0" cy="0"/>
+          <a:chOff x="0" y="0"/>
+          <a:chExt cx="0" cy="0"/>
+        </a:xfrm>
+      </p:grpSpPr>
       <p:sp>
         <p:nvSpPr>
           <p:cNvPr id="2" name="TextBox 1"/>
@@ -6513,6 +6743,7 @@
           <a:lstStyle/>
           <a:p>
             <a:pPr algn="ctr"/>
+            <a:endParaRPr/>
           </a:p>
         </p:txBody>
       </p:sp>

</xml_diff>